<commit_message>
Module 11 Final Submission and Peer Review Updates
Addressed peer review feedback by improving page spacing and layouts, updating the PowerPoint presentation, and reviewing error-message validation across the website. Added Reservation History improvements and Contact Us updates to the About page. Included the completed functional testing document, peer review modifications summary, and final project deliverables. All changes and files can be found in Module 11 deliverable zip.
</commit_message>
<xml_diff>
--- a/docs/Red Team Final Presentation.pptx
+++ b/docs/Red Team Final Presentation.pptx
@@ -211,7 +211,7 @@
           <a:p>
             <a:fld id="{3635DB15-7D6E-4472-B99D-9906CF1DE234}" type="datetimeFigureOut">
               <a:rPr lang="en-US" smtClean="0"/>
-              <a:t>10/4/2026</a:t>
+              <a:t>10/11/2026</a:t>
             </a:fld>
             <a:endParaRPr lang="en-US"/>
           </a:p>
@@ -1633,7 +1633,7 @@
           <a:p>
             <a:fld id="{DD5FEBA2-C475-4F4F-B1DA-6AC3BCF25491}" type="datetimeFigureOut">
               <a:rPr lang="en-US" smtClean="0"/>
-              <a:t>10/4/2026</a:t>
+              <a:t>10/11/2026</a:t>
             </a:fld>
             <a:endParaRPr lang="en-US"/>
           </a:p>
@@ -1831,7 +1831,7 @@
           <a:p>
             <a:fld id="{DD5FEBA2-C475-4F4F-B1DA-6AC3BCF25491}" type="datetimeFigureOut">
               <a:rPr lang="en-US" smtClean="0"/>
-              <a:t>10/4/2026</a:t>
+              <a:t>10/11/2026</a:t>
             </a:fld>
             <a:endParaRPr lang="en-US"/>
           </a:p>
@@ -2039,7 +2039,7 @@
           <a:p>
             <a:fld id="{DD5FEBA2-C475-4F4F-B1DA-6AC3BCF25491}" type="datetimeFigureOut">
               <a:rPr lang="en-US" smtClean="0"/>
-              <a:t>10/4/2026</a:t>
+              <a:t>10/11/2026</a:t>
             </a:fld>
             <a:endParaRPr lang="en-US"/>
           </a:p>
@@ -2137,7 +2137,7 @@
     </p:spTree>
     <p:extLst>
       <p:ext uri="{BB962C8B-B14F-4D97-AF65-F5344CB8AC3E}">
-        <p14:creationId xmlns:p14="http://schemas.microsoft.com/office/powerpoint/2010/main" val="859035783"/>
+        <p14:creationId xmlns:p14="http://schemas.microsoft.com/office/powerpoint/2010/main" val="3659857195"/>
       </p:ext>
     </p:extLst>
   </p:cSld>
@@ -2272,7 +2272,7 @@
           <a:p>
             <a:fld id="{DD5FEBA2-C475-4F4F-B1DA-6AC3BCF25491}" type="datetimeFigureOut">
               <a:rPr lang="en-US" smtClean="0"/>
-              <a:t>10/4/2026</a:t>
+              <a:t>10/11/2026</a:t>
             </a:fld>
             <a:endParaRPr lang="en-US"/>
           </a:p>
@@ -2547,7 +2547,7 @@
           <a:p>
             <a:fld id="{DD5FEBA2-C475-4F4F-B1DA-6AC3BCF25491}" type="datetimeFigureOut">
               <a:rPr lang="en-US" smtClean="0"/>
-              <a:t>10/4/2026</a:t>
+              <a:t>10/11/2026</a:t>
             </a:fld>
             <a:endParaRPr lang="en-US"/>
           </a:p>
@@ -2812,7 +2812,7 @@
           <a:p>
             <a:fld id="{DD5FEBA2-C475-4F4F-B1DA-6AC3BCF25491}" type="datetimeFigureOut">
               <a:rPr lang="en-US" smtClean="0"/>
-              <a:t>10/4/2026</a:t>
+              <a:t>10/11/2026</a:t>
             </a:fld>
             <a:endParaRPr lang="en-US"/>
           </a:p>
@@ -3224,7 +3224,7 @@
           <a:p>
             <a:fld id="{DD5FEBA2-C475-4F4F-B1DA-6AC3BCF25491}" type="datetimeFigureOut">
               <a:rPr lang="en-US" smtClean="0"/>
-              <a:t>10/4/2026</a:t>
+              <a:t>10/11/2026</a:t>
             </a:fld>
             <a:endParaRPr lang="en-US"/>
           </a:p>
@@ -3365,7 +3365,7 @@
           <a:p>
             <a:fld id="{DD5FEBA2-C475-4F4F-B1DA-6AC3BCF25491}" type="datetimeFigureOut">
               <a:rPr lang="en-US" smtClean="0"/>
-              <a:t>10/4/2026</a:t>
+              <a:t>10/11/2026</a:t>
             </a:fld>
             <a:endParaRPr lang="en-US"/>
           </a:p>
@@ -3478,7 +3478,7 @@
           <a:p>
             <a:fld id="{DD5FEBA2-C475-4F4F-B1DA-6AC3BCF25491}" type="datetimeFigureOut">
               <a:rPr lang="en-US" smtClean="0"/>
-              <a:t>10/4/2026</a:t>
+              <a:t>10/11/2026</a:t>
             </a:fld>
             <a:endParaRPr lang="en-US"/>
           </a:p>
@@ -3789,7 +3789,7 @@
           <a:p>
             <a:fld id="{DD5FEBA2-C475-4F4F-B1DA-6AC3BCF25491}" type="datetimeFigureOut">
               <a:rPr lang="en-US" smtClean="0"/>
-              <a:t>10/4/2026</a:t>
+              <a:t>10/11/2026</a:t>
             </a:fld>
             <a:endParaRPr lang="en-US"/>
           </a:p>
@@ -4077,7 +4077,7 @@
           <a:p>
             <a:fld id="{DD5FEBA2-C475-4F4F-B1DA-6AC3BCF25491}" type="datetimeFigureOut">
               <a:rPr lang="en-US" smtClean="0"/>
-              <a:t>10/4/2026</a:t>
+              <a:t>10/11/2026</a:t>
             </a:fld>
             <a:endParaRPr lang="en-US"/>
           </a:p>
@@ -4318,7 +4318,7 @@
           <a:p>
             <a:fld id="{DD5FEBA2-C475-4F4F-B1DA-6AC3BCF25491}" type="datetimeFigureOut">
               <a:rPr lang="en-US" smtClean="0"/>
-              <a:t>10/4/2026</a:t>
+              <a:t>10/11/2026</a:t>
             </a:fld>
             <a:endParaRPr lang="en-US"/>
           </a:p>
@@ -14031,7 +14031,7 @@
               </a:defRPr>
             </a:pPr>
             <a:r>
-              <a:t>How the prototype stores guests, room types, room inventory, reservations, and contact messages.</a:t>
+              <a:t>Relationships behind booking and guest history.</a:t>
             </a:r>
           </a:p>
         </p:txBody>
@@ -14113,7 +14113,7 @@
               </a:defRPr>
             </a:pPr>
             <a:r>
-              <a:t>What the ERD supports</a:t>
+              <a:t>How the tables connect</a:t>
             </a:r>
           </a:p>
         </p:txBody>
@@ -14152,7 +14152,7 @@
               </a:defRPr>
             </a:pPr>
             <a:r>
-              <a:t>Customers create reservations and can return later to review booking history.</a:t>
+              <a:t>Customers → reservations</a:t>
             </a:r>
           </a:p>
           <a:p>
@@ -14168,7 +14168,7 @@
               </a:defRPr>
             </a:pPr>
             <a:r>
-              <a:t>Room_Types define the room name, nightly price, and max occupancy used by the site.</a:t>
+              <a:t>Room types → prices and occupancy</a:t>
             </a:r>
           </a:p>
           <a:p>
@@ -14184,7 +14184,7 @@
               </a:defRPr>
             </a:pPr>
             <a:r>
-              <a:t>Rooms connect physical room numbers to a room type and control whether a room can be reserved.</a:t>
+              <a:t>Rooms → available room numbers</a:t>
             </a:r>
           </a:p>
           <a:p>
@@ -14200,7 +14200,7 @@
               </a:defRPr>
             </a:pPr>
             <a:r>
-              <a:t>Reservation_Rooms links each reservation to the assigned room and stores the nightly rate used at booking.</a:t>
+              <a:t>Reservation rooms → booking details</a:t>
             </a:r>
           </a:p>
           <a:p>
@@ -14216,7 +14216,7 @@
               </a:defRPr>
             </a:pPr>
             <a:r>
-              <a:t>Contact_Messages keeps guest questions separate from reservation data while still supporting the Contact page.</a:t>
+              <a:t>Contact messages → guest questions</a:t>
             </a:r>
           </a:p>
         </p:txBody>
@@ -14298,7 +14298,7 @@
               </a:defRPr>
             </a:pPr>
             <a:r>
-              <a:t>This structure supports room availability checks, reservation summary totals, reservation history, and contact form testing.</a:t>
+              <a:t>Supports availability, bookings, history, and contact.</a:t>
             </a:r>
           </a:p>
         </p:txBody>
@@ -14402,7 +14402,7 @@
               </a:defRPr>
             </a:pPr>
             <a:r>
-              <a:t>Each test includes the purpose, expected behavior, and screenshot evidence from the working prototype.</a:t>
+              <a:t>Five key tests passed. Screenshots show the results.</a:t>
             </a:r>
           </a:p>
         </p:txBody>
@@ -14636,7 +14636,7 @@
               </a:defRPr>
             </a:pPr>
             <a:r>
-              <a:t>Verify Reservation Lookup Connects to the Database</a:t>
+              <a:t>Reservation History Loads</a:t>
             </a:r>
           </a:p>
           <a:p>
@@ -14652,7 +14652,7 @@
               </a:defRPr>
             </a:pPr>
             <a:r>
-              <a:t>Confirms a logged-in guest can open reservation history and see records pulled from the database.</a:t>
+              <a:t>Saved customer reservations are shown.</a:t>
             </a:r>
           </a:p>
         </p:txBody>
@@ -14688,7 +14688,7 @@
               </a:defRPr>
             </a:pPr>
             <a:r>
-              <a:t>Passed. Saved reservations loaded with check-in date, check-out date, and total price.</a:t>
+              <a:t>Passed: dates and totals loaded.</a:t>
             </a:r>
           </a:p>
         </p:txBody>
@@ -14770,7 +14770,7 @@
               </a:defRPr>
             </a:pPr>
             <a:r>
-              <a:t>Verify Reservation Details Expand</a:t>
+              <a:t>Reservation Details Expand</a:t>
             </a:r>
           </a:p>
           <a:p>
@@ -14786,7 +14786,7 @@
               </a:defRPr>
             </a:pPr>
             <a:r>
-              <a:t>Checks that a reservation can expand to show the room type, room number, nightly rate, nights, and subtotal.</a:t>
+              <a:t>Room information opens on selection.</a:t>
             </a:r>
           </a:p>
         </p:txBody>
@@ -14822,7 +14822,7 @@
               </a:defRPr>
             </a:pPr>
             <a:r>
-              <a:t>Passed. Expanded details displayed the expected room rows and matching subtotal values.</a:t>
+              <a:t>Passed: room rows and subtotals match.</a:t>
             </a:r>
           </a:p>
         </p:txBody>
@@ -14904,7 +14904,7 @@
               </a:defRPr>
             </a:pPr>
             <a:r>
-              <a:t>About Page Loads with Merged Contact Section</a:t>
+              <a:t>About + Contact Form</a:t>
             </a:r>
           </a:p>
           <a:p>
@@ -14920,7 +14920,7 @@
               </a:defRPr>
             </a:pPr>
             <a:r>
-              <a:t>Verifies the merged About and Contact content loads together, including the contact form fields.</a:t>
+              <a:t>The combined page loads correctly.</a:t>
             </a:r>
           </a:p>
         </p:txBody>
@@ -14956,7 +14956,7 @@
               </a:defRPr>
             </a:pPr>
             <a:r>
-              <a:t>Passed. The page loaded contact details and the inquiry form without breaking the layout.</a:t>
+              <a:t>Passed: inquiry fields are visible.</a:t>
             </a:r>
           </a:p>
         </p:txBody>
@@ -15038,7 +15038,7 @@
               </a:defRPr>
             </a:pPr>
             <a:r>
-              <a:t>Room Available for Selected Dates</a:t>
+              <a:t>Booking Summary</a:t>
             </a:r>
           </a:p>
           <a:p>
@@ -15054,7 +15054,7 @@
               </a:defRPr>
             </a:pPr>
             <a:r>
-              <a:t>Confirms a valid room request can continue to the summary page and calculate the stay total.</a:t>
+              <a:t>Guests review their selected stay.</a:t>
             </a:r>
           </a:p>
         </p:txBody>
@@ -15090,7 +15090,7 @@
               </a:defRPr>
             </a:pPr>
             <a:r>
-              <a:t>Passed. The summary showed the selected room, dates, guest count, nightly rate, and total.</a:t>
+              <a:t>Passed: dates and total match.</a:t>
             </a:r>
           </a:p>
         </p:txBody>
@@ -15172,7 +15172,7 @@
               </a:defRPr>
             </a:pPr>
             <a:r>
-              <a:t>Insufficient Rooms Are Rejected</a:t>
+              <a:t>Availability Checks</a:t>
             </a:r>
           </a:p>
           <a:p>
@@ -15188,7 +15188,7 @@
               </a:defRPr>
             </a:pPr>
             <a:r>
-              <a:t>Tests that the reservation form blocks a request when the guest asks for more rooms than available.</a:t>
+              <a:t>Too many requested rooms are blocked.</a:t>
             </a:r>
           </a:p>
         </p:txBody>
@@ -15224,7 +15224,7 @@
               </a:defRPr>
             </a:pPr>
             <a:r>
-              <a:t>Passed. The page showed a clear availability message and stopped the reservation from continuing.</a:t>
+              <a:t>Passed: clear availability warning.</a:t>
             </a:r>
           </a:p>
         </p:txBody>

</xml_diff>

<commit_message>
Module 11 Final Submission and Peer Review Updates (#144)
Addressed peer review feedback by improving page spacing and layouts, updating the PowerPoint presentation, and reviewing error-message validation across the website. Added Reservation History improvements and Contact Us updates to the About page. Included the completed functional testing document, peer review modifications summary, and final project deliverables. All changes and files can be found in Module 11 deliverable zip.
</commit_message>
<xml_diff>
--- a/docs/Red Team Final Presentation.pptx
+++ b/docs/Red Team Final Presentation.pptx
@@ -211,7 +211,7 @@
           <a:p>
             <a:fld id="{3635DB15-7D6E-4472-B99D-9906CF1DE234}" type="datetimeFigureOut">
               <a:rPr lang="en-US" smtClean="0"/>
-              <a:t>10/4/2026</a:t>
+              <a:t>10/11/2026</a:t>
             </a:fld>
             <a:endParaRPr lang="en-US"/>
           </a:p>
@@ -1633,7 +1633,7 @@
           <a:p>
             <a:fld id="{DD5FEBA2-C475-4F4F-B1DA-6AC3BCF25491}" type="datetimeFigureOut">
               <a:rPr lang="en-US" smtClean="0"/>
-              <a:t>10/4/2026</a:t>
+              <a:t>10/11/2026</a:t>
             </a:fld>
             <a:endParaRPr lang="en-US"/>
           </a:p>
@@ -1831,7 +1831,7 @@
           <a:p>
             <a:fld id="{DD5FEBA2-C475-4F4F-B1DA-6AC3BCF25491}" type="datetimeFigureOut">
               <a:rPr lang="en-US" smtClean="0"/>
-              <a:t>10/4/2026</a:t>
+              <a:t>10/11/2026</a:t>
             </a:fld>
             <a:endParaRPr lang="en-US"/>
           </a:p>
@@ -2039,7 +2039,7 @@
           <a:p>
             <a:fld id="{DD5FEBA2-C475-4F4F-B1DA-6AC3BCF25491}" type="datetimeFigureOut">
               <a:rPr lang="en-US" smtClean="0"/>
-              <a:t>10/4/2026</a:t>
+              <a:t>10/11/2026</a:t>
             </a:fld>
             <a:endParaRPr lang="en-US"/>
           </a:p>
@@ -2137,7 +2137,7 @@
     </p:spTree>
     <p:extLst>
       <p:ext uri="{BB962C8B-B14F-4D97-AF65-F5344CB8AC3E}">
-        <p14:creationId xmlns:p14="http://schemas.microsoft.com/office/powerpoint/2010/main" val="859035783"/>
+        <p14:creationId xmlns:p14="http://schemas.microsoft.com/office/powerpoint/2010/main" val="3659857195"/>
       </p:ext>
     </p:extLst>
   </p:cSld>
@@ -2272,7 +2272,7 @@
           <a:p>
             <a:fld id="{DD5FEBA2-C475-4F4F-B1DA-6AC3BCF25491}" type="datetimeFigureOut">
               <a:rPr lang="en-US" smtClean="0"/>
-              <a:t>10/4/2026</a:t>
+              <a:t>10/11/2026</a:t>
             </a:fld>
             <a:endParaRPr lang="en-US"/>
           </a:p>
@@ -2547,7 +2547,7 @@
           <a:p>
             <a:fld id="{DD5FEBA2-C475-4F4F-B1DA-6AC3BCF25491}" type="datetimeFigureOut">
               <a:rPr lang="en-US" smtClean="0"/>
-              <a:t>10/4/2026</a:t>
+              <a:t>10/11/2026</a:t>
             </a:fld>
             <a:endParaRPr lang="en-US"/>
           </a:p>
@@ -2812,7 +2812,7 @@
           <a:p>
             <a:fld id="{DD5FEBA2-C475-4F4F-B1DA-6AC3BCF25491}" type="datetimeFigureOut">
               <a:rPr lang="en-US" smtClean="0"/>
-              <a:t>10/4/2026</a:t>
+              <a:t>10/11/2026</a:t>
             </a:fld>
             <a:endParaRPr lang="en-US"/>
           </a:p>
@@ -3224,7 +3224,7 @@
           <a:p>
             <a:fld id="{DD5FEBA2-C475-4F4F-B1DA-6AC3BCF25491}" type="datetimeFigureOut">
               <a:rPr lang="en-US" smtClean="0"/>
-              <a:t>10/4/2026</a:t>
+              <a:t>10/11/2026</a:t>
             </a:fld>
             <a:endParaRPr lang="en-US"/>
           </a:p>
@@ -3365,7 +3365,7 @@
           <a:p>
             <a:fld id="{DD5FEBA2-C475-4F4F-B1DA-6AC3BCF25491}" type="datetimeFigureOut">
               <a:rPr lang="en-US" smtClean="0"/>
-              <a:t>10/4/2026</a:t>
+              <a:t>10/11/2026</a:t>
             </a:fld>
             <a:endParaRPr lang="en-US"/>
           </a:p>
@@ -3478,7 +3478,7 @@
           <a:p>
             <a:fld id="{DD5FEBA2-C475-4F4F-B1DA-6AC3BCF25491}" type="datetimeFigureOut">
               <a:rPr lang="en-US" smtClean="0"/>
-              <a:t>10/4/2026</a:t>
+              <a:t>10/11/2026</a:t>
             </a:fld>
             <a:endParaRPr lang="en-US"/>
           </a:p>
@@ -3789,7 +3789,7 @@
           <a:p>
             <a:fld id="{DD5FEBA2-C475-4F4F-B1DA-6AC3BCF25491}" type="datetimeFigureOut">
               <a:rPr lang="en-US" smtClean="0"/>
-              <a:t>10/4/2026</a:t>
+              <a:t>10/11/2026</a:t>
             </a:fld>
             <a:endParaRPr lang="en-US"/>
           </a:p>
@@ -4077,7 +4077,7 @@
           <a:p>
             <a:fld id="{DD5FEBA2-C475-4F4F-B1DA-6AC3BCF25491}" type="datetimeFigureOut">
               <a:rPr lang="en-US" smtClean="0"/>
-              <a:t>10/4/2026</a:t>
+              <a:t>10/11/2026</a:t>
             </a:fld>
             <a:endParaRPr lang="en-US"/>
           </a:p>
@@ -4318,7 +4318,7 @@
           <a:p>
             <a:fld id="{DD5FEBA2-C475-4F4F-B1DA-6AC3BCF25491}" type="datetimeFigureOut">
               <a:rPr lang="en-US" smtClean="0"/>
-              <a:t>10/4/2026</a:t>
+              <a:t>10/11/2026</a:t>
             </a:fld>
             <a:endParaRPr lang="en-US"/>
           </a:p>
@@ -14031,7 +14031,7 @@
               </a:defRPr>
             </a:pPr>
             <a:r>
-              <a:t>How the prototype stores guests, room types, room inventory, reservations, and contact messages.</a:t>
+              <a:t>Relationships behind booking and guest history.</a:t>
             </a:r>
           </a:p>
         </p:txBody>
@@ -14113,7 +14113,7 @@
               </a:defRPr>
             </a:pPr>
             <a:r>
-              <a:t>What the ERD supports</a:t>
+              <a:t>How the tables connect</a:t>
             </a:r>
           </a:p>
         </p:txBody>
@@ -14152,7 +14152,7 @@
               </a:defRPr>
             </a:pPr>
             <a:r>
-              <a:t>Customers create reservations and can return later to review booking history.</a:t>
+              <a:t>Customers → reservations</a:t>
             </a:r>
           </a:p>
           <a:p>
@@ -14168,7 +14168,7 @@
               </a:defRPr>
             </a:pPr>
             <a:r>
-              <a:t>Room_Types define the room name, nightly price, and max occupancy used by the site.</a:t>
+              <a:t>Room types → prices and occupancy</a:t>
             </a:r>
           </a:p>
           <a:p>
@@ -14184,7 +14184,7 @@
               </a:defRPr>
             </a:pPr>
             <a:r>
-              <a:t>Rooms connect physical room numbers to a room type and control whether a room can be reserved.</a:t>
+              <a:t>Rooms → available room numbers</a:t>
             </a:r>
           </a:p>
           <a:p>
@@ -14200,7 +14200,7 @@
               </a:defRPr>
             </a:pPr>
             <a:r>
-              <a:t>Reservation_Rooms links each reservation to the assigned room and stores the nightly rate used at booking.</a:t>
+              <a:t>Reservation rooms → booking details</a:t>
             </a:r>
           </a:p>
           <a:p>
@@ -14216,7 +14216,7 @@
               </a:defRPr>
             </a:pPr>
             <a:r>
-              <a:t>Contact_Messages keeps guest questions separate from reservation data while still supporting the Contact page.</a:t>
+              <a:t>Contact messages → guest questions</a:t>
             </a:r>
           </a:p>
         </p:txBody>
@@ -14298,7 +14298,7 @@
               </a:defRPr>
             </a:pPr>
             <a:r>
-              <a:t>This structure supports room availability checks, reservation summary totals, reservation history, and contact form testing.</a:t>
+              <a:t>Supports availability, bookings, history, and contact.</a:t>
             </a:r>
           </a:p>
         </p:txBody>
@@ -14402,7 +14402,7 @@
               </a:defRPr>
             </a:pPr>
             <a:r>
-              <a:t>Each test includes the purpose, expected behavior, and screenshot evidence from the working prototype.</a:t>
+              <a:t>Five key tests passed. Screenshots show the results.</a:t>
             </a:r>
           </a:p>
         </p:txBody>
@@ -14636,7 +14636,7 @@
               </a:defRPr>
             </a:pPr>
             <a:r>
-              <a:t>Verify Reservation Lookup Connects to the Database</a:t>
+              <a:t>Reservation History Loads</a:t>
             </a:r>
           </a:p>
           <a:p>
@@ -14652,7 +14652,7 @@
               </a:defRPr>
             </a:pPr>
             <a:r>
-              <a:t>Confirms a logged-in guest can open reservation history and see records pulled from the database.</a:t>
+              <a:t>Saved customer reservations are shown.</a:t>
             </a:r>
           </a:p>
         </p:txBody>
@@ -14688,7 +14688,7 @@
               </a:defRPr>
             </a:pPr>
             <a:r>
-              <a:t>Passed. Saved reservations loaded with check-in date, check-out date, and total price.</a:t>
+              <a:t>Passed: dates and totals loaded.</a:t>
             </a:r>
           </a:p>
         </p:txBody>
@@ -14770,7 +14770,7 @@
               </a:defRPr>
             </a:pPr>
             <a:r>
-              <a:t>Verify Reservation Details Expand</a:t>
+              <a:t>Reservation Details Expand</a:t>
             </a:r>
           </a:p>
           <a:p>
@@ -14786,7 +14786,7 @@
               </a:defRPr>
             </a:pPr>
             <a:r>
-              <a:t>Checks that a reservation can expand to show the room type, room number, nightly rate, nights, and subtotal.</a:t>
+              <a:t>Room information opens on selection.</a:t>
             </a:r>
           </a:p>
         </p:txBody>
@@ -14822,7 +14822,7 @@
               </a:defRPr>
             </a:pPr>
             <a:r>
-              <a:t>Passed. Expanded details displayed the expected room rows and matching subtotal values.</a:t>
+              <a:t>Passed: room rows and subtotals match.</a:t>
             </a:r>
           </a:p>
         </p:txBody>
@@ -14904,7 +14904,7 @@
               </a:defRPr>
             </a:pPr>
             <a:r>
-              <a:t>About Page Loads with Merged Contact Section</a:t>
+              <a:t>About + Contact Form</a:t>
             </a:r>
           </a:p>
           <a:p>
@@ -14920,7 +14920,7 @@
               </a:defRPr>
             </a:pPr>
             <a:r>
-              <a:t>Verifies the merged About and Contact content loads together, including the contact form fields.</a:t>
+              <a:t>The combined page loads correctly.</a:t>
             </a:r>
           </a:p>
         </p:txBody>
@@ -14956,7 +14956,7 @@
               </a:defRPr>
             </a:pPr>
             <a:r>
-              <a:t>Passed. The page loaded contact details and the inquiry form without breaking the layout.</a:t>
+              <a:t>Passed: inquiry fields are visible.</a:t>
             </a:r>
           </a:p>
         </p:txBody>
@@ -15038,7 +15038,7 @@
               </a:defRPr>
             </a:pPr>
             <a:r>
-              <a:t>Room Available for Selected Dates</a:t>
+              <a:t>Booking Summary</a:t>
             </a:r>
           </a:p>
           <a:p>
@@ -15054,7 +15054,7 @@
               </a:defRPr>
             </a:pPr>
             <a:r>
-              <a:t>Confirms a valid room request can continue to the summary page and calculate the stay total.</a:t>
+              <a:t>Guests review their selected stay.</a:t>
             </a:r>
           </a:p>
         </p:txBody>
@@ -15090,7 +15090,7 @@
               </a:defRPr>
             </a:pPr>
             <a:r>
-              <a:t>Passed. The summary showed the selected room, dates, guest count, nightly rate, and total.</a:t>
+              <a:t>Passed: dates and total match.</a:t>
             </a:r>
           </a:p>
         </p:txBody>
@@ -15172,7 +15172,7 @@
               </a:defRPr>
             </a:pPr>
             <a:r>
-              <a:t>Insufficient Rooms Are Rejected</a:t>
+              <a:t>Availability Checks</a:t>
             </a:r>
           </a:p>
           <a:p>
@@ -15188,7 +15188,7 @@
               </a:defRPr>
             </a:pPr>
             <a:r>
-              <a:t>Tests that the reservation form blocks a request when the guest asks for more rooms than available.</a:t>
+              <a:t>Too many requested rooms are blocked.</a:t>
             </a:r>
           </a:p>
         </p:txBody>
@@ -15224,7 +15224,7 @@
               </a:defRPr>
             </a:pPr>
             <a:r>
-              <a:t>Passed. The page showed a clear availability message and stopped the reservation from continuing.</a:t>
+              <a:t>Passed: clear availability warning.</a:t>
             </a:r>
           </a:p>
         </p:txBody>

</xml_diff>